<commit_message>
Say what the Elmina figures really are: a 1,368-roof, 2-assumed-buyer example
- "Elmina size" is now "the 1,368-roof Elmina example (2 assumed buyers)" in the app, testing suite, README and replay.py text
- Final pitch deck and PDF refreshed with the same wording

Co-Authored-By: Claude Sonnet 5.5 <noreply@anthropic.com>
</commit_message>
<xml_diff>
--- a/00 Documents/WattWise Pitch Deck (final).pptx
+++ b/00 Documents/WattWise Pitch Deck (final).pptx
@@ -1294,7 +1294,7 @@
               <c:strCache>
                 <c:ptCount val="1"/>
                 <c:pt idx="0">
-                  <c:v>Elmina's modelled size (1,368 roofs)</c:v>
+                  <c:v>Elmina example (1,368 roofs, 2 assumed buyers)</c:v>
                 </c:pt>
               </c:strCache>
             </c:strRef>
@@ -1363,16 +1363,16 @@
             <c:numRef>
               <c:f>Sheet1!$B$2:$B$4</c:f>
               <c:numCache>
-                <c:formatCode>General</c:formatCode>
+                <c:formatCode>0</c:formatCode>
                 <c:ptCount val="3"/>
                 <c:pt idx="0">
-                  <c:v>60</c:v>
+                  <c:v>60.0</c:v>
                 </c:pt>
                 <c:pt idx="1">
-                  <c:v>42</c:v>
+                  <c:v>42.0</c:v>
                 </c:pt>
                 <c:pt idx="2">
-                  <c:v>25</c:v>
+                  <c:v>25.0</c:v>
                 </c:pt>
               </c:numCache>
             </c:numRef>
@@ -1470,16 +1470,16 @@
             <c:numRef>
               <c:f>Sheet1!$C$2:$C$4</c:f>
               <c:numCache>
-                <c:formatCode>General</c:formatCode>
+                <c:formatCode>0</c:formatCode>
                 <c:ptCount val="3"/>
                 <c:pt idx="0">
-                  <c:v>265</c:v>
+                  <c:v>265.0</c:v>
                 </c:pt>
                 <c:pt idx="1">
-                  <c:v>184</c:v>
+                  <c:v>184.0</c:v>
                 </c:pt>
                 <c:pt idx="2">
-                  <c:v>108</c:v>
+                  <c:v>108.0</c:v>
                 </c:pt>
               </c:numCache>
             </c:numRef>
@@ -16637,7 +16637,7 @@
                 </a:solidFill>
                 <a:latin typeface="Calibri"/>
               </a:rPr>
-              <a:t>At Elmina size: </a:t>
+              <a:t>For the 1,368-roof Elmina example (2 assumed buyers): </a:t>
             </a:r>
             <a:r>
               <a:rPr sz="1400" b="0">

</xml_diff>